<commit_message>
Update EU_SAE PDF metadata and replace PPTX
Regenerated the EU_SAE_Download_Instructions_v5_0_1.pdf: updated CreationDate/ModDate timestamps, adjusted stream length and content, updated xref/ID and startxref entries. Also replaced the binary EU_SAE_User_Guide_Dashboard_v5_0_1.pptx with a new version.
</commit_message>
<xml_diff>
--- a/instructions/EU_SAE_User_Guide_Dashboard_v5_0_1.pptx
+++ b/instructions/EU_SAE_User_Guide_Dashboard_v5_0_1.pptx
@@ -5456,7 +5456,7 @@
                 <a:ea typeface="Calibri"/>
                 <a:cs typeface="Calibri"/>
               </a:rPr>
-              <a:t>Choose a convenient location, e.g. Documents/EU_SAE_application_package</a:t>
+              <a:t>Choose a convenient location. The extracted folder name may include the release tag.</a:t>
             </a:r>
           </a:p>
         </p:txBody>
@@ -5584,7 +5584,7 @@
                 <a:ea typeface="Calibri"/>
                 <a:cs typeface="Calibri"/>
               </a:rPr>
-              <a:t>You should see Start_Dashboard.bat, app.R, R/, scripts/, data/, outputs/, instructions/, and www/.</a:t>
+              <a:t>Open the extracted folder that contains Start_Dashboard.bat, app.R, R/, scripts/, data/, outputs/, instructions/, and www/. You may rename it to EU_SAE_application_package if helpful.</a:t>
             </a:r>
           </a:p>
         </p:txBody>
@@ -5667,7 +5667,7 @@
                 <a:ea typeface="Consolas"/>
                 <a:cs typeface="Consolas"/>
               </a:rPr>
-              <a:t>EU_SAE_application_package/</a:t>
+              <a:t>extracted package folder/</a:t>
             </a:r>
           </a:p>
           <a:p xmlns:a="http://schemas.openxmlformats.org/drawingml/2006/main">
@@ -7681,7 +7681,7 @@
                 <a:ea typeface="Calibri"/>
                 <a:cs typeface="Calibri"/>
               </a:rPr>
-              <a:t>Double-click the Windows launcher or run the shell script. Your browser opens the first available local URL, usually http://127.0.0.1:7777.</a:t>
+              <a:t>From the extracted package folder, double-click the Windows launcher or run the shell script. Your browser opens the first available local URL, usually http://127.0.0.1:7777.</a:t>
             </a:r>
           </a:p>
         </p:txBody>

</xml_diff>